<commit_message>
Point to the presentation from the README; align the user description on slide 2
</commit_message>
<xml_diff>
--- a/presentation/PRAMAAN.pptx
+++ b/presentation/PRAMAAN.pptx
@@ -9185,7 +9185,7 @@
                 <a:ea typeface="Calibri" pitchFamily="34" charset="-122"/>
                 <a:cs typeface="Calibri" pitchFamily="34" charset="-120"/>
               </a:rPr>
-              <a:t>Someone deciding whether to act on an investment claim about a listed Nepali company.</a:t>
+              <a:t>Individuals investing small and medium amounts in NEPSE — people in full-time jobs who invest on the side, without the time, or in some cases the financial background, to check whether advice about a company rests on any evidence.</a:t>
             </a:r>
             <a:endParaRPr lang="en-US" sz="1100" dirty="0"/>
           </a:p>
@@ -9214,7 +9214,7 @@
                 <a:ea typeface="Calibri" pitchFamily="34" charset="-122"/>
                 <a:cs typeface="Calibri" pitchFamily="34" charset="-120"/>
               </a:rPr>
-              <a:t>The figures in the claim may well be real. What is missing is a fast way to see where each one comes from, and whether it supports the conclusion drawn from it.</a:t>
+              <a:t>The figures in a claim may well be real. What is missing is a fast way to see where each one comes from, and whether it supports the conclusion drawn from it.</a:t>
             </a:r>
             <a:endParaRPr lang="en-US" sz="1100" dirty="0"/>
           </a:p>

</xml_diff>

<commit_message>
presentation: six accuracy fixes to slide claims
</commit_message>
<xml_diff>
--- a/presentation/PRAMAAN.pptx
+++ b/presentation/PRAMAAN.pptx
@@ -1779,7 +1779,7 @@
           <a:p>
             <a:r>
               <a:rPr lang="en-US" dirty="0"/>
-              <a:t>This is the README's opening framing: intended user, current bottleneck, why solving it is valuable. Stated as what a user WOULD get, not what one has got — no user has used this. The four manual steps are the real bottleneck, and step four is the one non-specialists miss. Sources: README.md, DECISIONS.md 29 August on the SEBON policy.</a:t>
+              <a:t>This is the README's opening framing: intended user, current bottleneck, why solving it is valuable. Stated as what a user WOULD get, not what one has got — no user has used this. The four manual steps are the real bottleneck, and step four is the one non-specialists miss. Sources: README.md for the user and bottleneck; DECISIONS.md, 29 August, for the SEBON policy.</a:t>
             </a:r>
             <a:endParaRPr lang="en-US" dirty="0"/>
           </a:p>
@@ -3834,7 +3834,7 @@
                 <a:ea typeface="Calibri" pitchFamily="34" charset="-122"/>
                 <a:cs typeface="Calibri" pitchFamily="34" charset="-120"/>
               </a:rPr>
-              <a:t>One variable per iteration, each with a prediction written before the run</a:t>
+              <a:t>One variable per iteration — except the last, which is why the control run exists</a:t>
             </a:r>
             <a:endParaRPr lang="en-US" sz="1300" dirty="0"/>
           </a:p>
@@ -7097,7 +7097,7 @@
                 <a:ea typeface="Calibri" pitchFamily="34" charset="-122"/>
                 <a:cs typeface="Calibri" pitchFamily="34" charset="-120"/>
               </a:rPr>
-              <a:t>A case study, not statistical power. The free tier allows twenty requests a day, and six runs of three cases is eighteen. The attribution result rests on a single case — the weakest evidence here.</a:t>
+              <a:t>A case study, not statistical power. The free tier allows twenty requests a day, and six runs of three cases is eighteen calls before any correction. The attribution result rests on a single case — the weakest evidence here.</a:t>
             </a:r>
             <a:endParaRPr lang="en-US" sz="1150" dirty="0"/>
           </a:p>
@@ -11481,7 +11481,7 @@
                 <a:ea typeface="Calibri" pitchFamily="34" charset="-122"/>
                 <a:cs typeface="Calibri" pitchFamily="34" charset="-120"/>
               </a:rPr>
-              <a:t>SEBON named unauthorised investment advice a live harm in July 2026, with licensing requirements and legal action planned — so the value of the problem is evidenced rather than asserted.</a:t>
+              <a:t>SEBON named unauthorised investment advice a live harm in July 2026, with licensing requirements and legal action planned — which is why these cases are synthetic rather than collected from real posts.</a:t>
             </a:r>
             <a:endParaRPr lang="en-US" sz="1100" dirty="0"/>
           </a:p>
@@ -13251,7 +13251,7 @@
                 <a:ea typeface="Calibri" pitchFamily="34" charset="-122"/>
                 <a:cs typeface="Calibri" pitchFamily="34" charset="-120"/>
               </a:rPr>
-              <a:t>The claim, plus a fixed corpus of published filings — each with its URL and a line stating what that file does and does not cover.</a:t>
+              <a:t>The claim, plus a fixed corpus of published figures — each with its URL and a line stating what that file does and does not cover.</a:t>
             </a:r>
             <a:endParaRPr lang="en-US" sz="950" dirty="0"/>
           </a:p>
@@ -17079,7 +17079,7 @@
                 <a:ea typeface="Calibri" pitchFamily="34" charset="-122"/>
                 <a:cs typeface="Calibri" pitchFamily="34" charset="-120"/>
               </a:rPr>
-              <a:t>Five runs plus a control — one variable changed per iteration</a:t>
+              <a:t>Five runs plus a control, scored on the same three cases</a:t>
             </a:r>
             <a:endParaRPr lang="en-US" sz="1300" dirty="0"/>
           </a:p>

</xml_diff>